<commit_message>
Test can now be run also in visual mode (Claude)
</commit_message>
<xml_diff>
--- a/doc/menu.pptx
+++ b/doc/menu.pptx
@@ -7,6 +7,9 @@
   <p:sldIdLst>
     <p:sldId id="256" r:id="rId2"/>
     <p:sldId id="257" r:id="rId3"/>
+    <p:sldId id="258" r:id="rId4"/>
+    <p:sldId id="259" r:id="rId5"/>
+    <p:sldId id="260" r:id="rId6"/>
   </p:sldIdLst>
   <p:sldSz cx="12192000" cy="6858000"/>
   <p:notesSz cx="6858000" cy="9144000"/>
@@ -262,7 +265,7 @@
           <a:p>
             <a:fld id="{6A848BCC-239D-4BFA-8FAE-67D36FFFE04A}" type="datetimeFigureOut">
               <a:rPr lang="fr-CH" smtClean="0"/>
-              <a:t>28.01.2026</a:t>
+              <a:t>09.09.2026</a:t>
             </a:fld>
             <a:endParaRPr lang="fr-CH"/>
           </a:p>
@@ -462,7 +465,7 @@
           <a:p>
             <a:fld id="{6A848BCC-239D-4BFA-8FAE-67D36FFFE04A}" type="datetimeFigureOut">
               <a:rPr lang="fr-CH" smtClean="0"/>
-              <a:t>28.01.2026</a:t>
+              <a:t>09.09.2026</a:t>
             </a:fld>
             <a:endParaRPr lang="fr-CH"/>
           </a:p>
@@ -672,7 +675,7 @@
           <a:p>
             <a:fld id="{6A848BCC-239D-4BFA-8FAE-67D36FFFE04A}" type="datetimeFigureOut">
               <a:rPr lang="fr-CH" smtClean="0"/>
-              <a:t>28.01.2026</a:t>
+              <a:t>09.09.2026</a:t>
             </a:fld>
             <a:endParaRPr lang="fr-CH"/>
           </a:p>
@@ -872,7 +875,7 @@
           <a:p>
             <a:fld id="{6A848BCC-239D-4BFA-8FAE-67D36FFFE04A}" type="datetimeFigureOut">
               <a:rPr lang="fr-CH" smtClean="0"/>
-              <a:t>28.01.2026</a:t>
+              <a:t>09.09.2026</a:t>
             </a:fld>
             <a:endParaRPr lang="fr-CH"/>
           </a:p>
@@ -1148,7 +1151,7 @@
           <a:p>
             <a:fld id="{6A848BCC-239D-4BFA-8FAE-67D36FFFE04A}" type="datetimeFigureOut">
               <a:rPr lang="fr-CH" smtClean="0"/>
-              <a:t>28.01.2026</a:t>
+              <a:t>09.09.2026</a:t>
             </a:fld>
             <a:endParaRPr lang="fr-CH"/>
           </a:p>
@@ -1416,7 +1419,7 @@
           <a:p>
             <a:fld id="{6A848BCC-239D-4BFA-8FAE-67D36FFFE04A}" type="datetimeFigureOut">
               <a:rPr lang="fr-CH" smtClean="0"/>
-              <a:t>28.01.2026</a:t>
+              <a:t>09.09.2026</a:t>
             </a:fld>
             <a:endParaRPr lang="fr-CH"/>
           </a:p>
@@ -1831,7 +1834,7 @@
           <a:p>
             <a:fld id="{6A848BCC-239D-4BFA-8FAE-67D36FFFE04A}" type="datetimeFigureOut">
               <a:rPr lang="fr-CH" smtClean="0"/>
-              <a:t>28.01.2026</a:t>
+              <a:t>09.09.2026</a:t>
             </a:fld>
             <a:endParaRPr lang="fr-CH"/>
           </a:p>
@@ -1973,7 +1976,7 @@
           <a:p>
             <a:fld id="{6A848BCC-239D-4BFA-8FAE-67D36FFFE04A}" type="datetimeFigureOut">
               <a:rPr lang="fr-CH" smtClean="0"/>
-              <a:t>28.01.2026</a:t>
+              <a:t>09.09.2026</a:t>
             </a:fld>
             <a:endParaRPr lang="fr-CH"/>
           </a:p>
@@ -2086,7 +2089,7 @@
           <a:p>
             <a:fld id="{6A848BCC-239D-4BFA-8FAE-67D36FFFE04A}" type="datetimeFigureOut">
               <a:rPr lang="fr-CH" smtClean="0"/>
-              <a:t>28.01.2026</a:t>
+              <a:t>09.09.2026</a:t>
             </a:fld>
             <a:endParaRPr lang="fr-CH"/>
           </a:p>
@@ -2399,7 +2402,7 @@
           <a:p>
             <a:fld id="{6A848BCC-239D-4BFA-8FAE-67D36FFFE04A}" type="datetimeFigureOut">
               <a:rPr lang="fr-CH" smtClean="0"/>
-              <a:t>28.01.2026</a:t>
+              <a:t>09.09.2026</a:t>
             </a:fld>
             <a:endParaRPr lang="fr-CH"/>
           </a:p>
@@ -2688,7 +2691,7 @@
           <a:p>
             <a:fld id="{6A848BCC-239D-4BFA-8FAE-67D36FFFE04A}" type="datetimeFigureOut">
               <a:rPr lang="fr-CH" smtClean="0"/>
-              <a:t>28.01.2026</a:t>
+              <a:t>09.09.2026</a:t>
             </a:fld>
             <a:endParaRPr lang="fr-CH"/>
           </a:p>
@@ -2931,7 +2934,7 @@
           <a:p>
             <a:fld id="{6A848BCC-239D-4BFA-8FAE-67D36FFFE04A}" type="datetimeFigureOut">
               <a:rPr lang="fr-CH" smtClean="0"/>
-              <a:t>28.01.2026</a:t>
+              <a:t>09.09.2026</a:t>
             </a:fld>
             <a:endParaRPr lang="fr-CH"/>
           </a:p>
@@ -4312,6 +4315,1060 @@
 </p:sld>
 </file>
 
+<file path=ppt/slides/slide3.xml><?xml version="1.0" encoding="utf-8"?>
+<p:sld xmlns:a="http://schemas.openxmlformats.org/drawingml/2006/main" xmlns:r="http://schemas.openxmlformats.org/officeDocument/2006/relationships" xmlns:p="http://schemas.openxmlformats.org/presentationml/2006/main">
+  <p:cSld>
+    <p:spTree>
+      <p:nvGrpSpPr>
+        <p:cNvPr id="1" name=""/>
+        <p:cNvGrpSpPr/>
+        <p:nvPr/>
+      </p:nvGrpSpPr>
+      <p:grpSpPr>
+        <a:xfrm>
+          <a:off x="0" y="0"/>
+          <a:ext cx="0" cy="0"/>
+          <a:chOff x="0" y="0"/>
+          <a:chExt cx="0" cy="0"/>
+        </a:xfrm>
+      </p:grpSpPr>
+      <p:pic>
+        <p:nvPicPr>
+          <p:cNvPr id="5" name="Picture 4">
+            <a:extLst>
+              <a:ext uri="{FF2B5EF4-FFF2-40B4-BE49-F238E27FC236}">
+                <a16:creationId xmlns:a16="http://schemas.microsoft.com/office/drawing/2014/main" id="{33A48E7B-39B7-4ACA-B8D9-812F6C138C6D}"/>
+              </a:ext>
+            </a:extLst>
+          </p:cNvPr>
+          <p:cNvPicPr>
+            <a:picLocks noChangeAspect="1"/>
+          </p:cNvPicPr>
+          <p:nvPr/>
+        </p:nvPicPr>
+        <p:blipFill>
+          <a:blip r:embed="rId2"/>
+          <a:stretch>
+            <a:fillRect/>
+          </a:stretch>
+        </p:blipFill>
+        <p:spPr>
+          <a:xfrm>
+            <a:off x="3838260" y="1280812"/>
+            <a:ext cx="4515480" cy="4296375"/>
+          </a:xfrm>
+          <a:prstGeom prst="rect">
+            <a:avLst/>
+          </a:prstGeom>
+        </p:spPr>
+      </p:pic>
+      <p:sp>
+        <p:nvSpPr>
+          <p:cNvPr id="8" name="TextBox 7">
+            <a:extLst>
+              <a:ext uri="{FF2B5EF4-FFF2-40B4-BE49-F238E27FC236}">
+                <a16:creationId xmlns:a16="http://schemas.microsoft.com/office/drawing/2014/main" id="{E1C186AF-7EEB-2581-7D9B-6B8B96AD8C3F}"/>
+              </a:ext>
+            </a:extLst>
+          </p:cNvPr>
+          <p:cNvSpPr txBox="1"/>
+          <p:nvPr/>
+        </p:nvSpPr>
+        <p:spPr>
+          <a:xfrm>
+            <a:off x="1950692" y="1457645"/>
+            <a:ext cx="1063753" cy="369332"/>
+          </a:xfrm>
+          <a:prstGeom prst="rect">
+            <a:avLst/>
+          </a:prstGeom>
+          <a:solidFill>
+            <a:schemeClr val="accent1">
+              <a:lumMod val="20000"/>
+              <a:lumOff val="80000"/>
+            </a:schemeClr>
+          </a:solidFill>
+        </p:spPr>
+        <p:txBody>
+          <a:bodyPr wrap="none" rtlCol="0">
+            <a:spAutoFit/>
+          </a:bodyPr>
+          <a:lstStyle/>
+          <a:p>
+            <a:r>
+              <a:rPr lang="fr-CH" dirty="0"/>
+              <a:t>X </a:t>
+            </a:r>
+            <a:r>
+              <a:rPr lang="fr-CH"/>
+              <a:t>= 0,</a:t>
+            </a:r>
+            <a:r>
+              <a:rPr lang="fr-CH" dirty="0"/>
+              <a:t>Y</a:t>
+            </a:r>
+            <a:r>
+              <a:rPr lang="fr-CH"/>
+              <a:t>=1</a:t>
+            </a:r>
+            <a:endParaRPr lang="fr-CH" dirty="0"/>
+          </a:p>
+        </p:txBody>
+      </p:sp>
+      <p:cxnSp>
+        <p:nvCxnSpPr>
+          <p:cNvPr id="10" name="Straight Arrow Connector 9">
+            <a:extLst>
+              <a:ext uri="{FF2B5EF4-FFF2-40B4-BE49-F238E27FC236}">
+                <a16:creationId xmlns:a16="http://schemas.microsoft.com/office/drawing/2014/main" id="{2A2455B2-E6E8-38B8-33E6-FFD6CDE767CB}"/>
+              </a:ext>
+            </a:extLst>
+          </p:cNvPr>
+          <p:cNvCxnSpPr>
+            <a:cxnSpLocks/>
+            <a:stCxn id="8" idx="3"/>
+          </p:cNvCxnSpPr>
+          <p:nvPr/>
+        </p:nvCxnSpPr>
+        <p:spPr>
+          <a:xfrm flipV="1">
+            <a:off x="3014445" y="1573859"/>
+            <a:ext cx="877771" cy="68452"/>
+          </a:xfrm>
+          <a:prstGeom prst="straightConnector1">
+            <a:avLst/>
+          </a:prstGeom>
+          <a:ln>
+            <a:tailEnd type="triangle"/>
+          </a:ln>
+        </p:spPr>
+        <p:style>
+          <a:lnRef idx="2">
+            <a:schemeClr val="accent1"/>
+          </a:lnRef>
+          <a:fillRef idx="0">
+            <a:schemeClr val="accent1"/>
+          </a:fillRef>
+          <a:effectRef idx="1">
+            <a:schemeClr val="accent1"/>
+          </a:effectRef>
+          <a:fontRef idx="minor">
+            <a:schemeClr val="tx1"/>
+          </a:fontRef>
+        </p:style>
+      </p:cxnSp>
+      <p:sp>
+        <p:nvSpPr>
+          <p:cNvPr id="12" name="TextBox 11">
+            <a:extLst>
+              <a:ext uri="{FF2B5EF4-FFF2-40B4-BE49-F238E27FC236}">
+                <a16:creationId xmlns:a16="http://schemas.microsoft.com/office/drawing/2014/main" id="{EDDB3A8B-DF75-7A24-DA14-8D686C95A2D0}"/>
+              </a:ext>
+            </a:extLst>
+          </p:cNvPr>
+          <p:cNvSpPr txBox="1"/>
+          <p:nvPr/>
+        </p:nvSpPr>
+        <p:spPr>
+          <a:xfrm>
+            <a:off x="6977633" y="1573859"/>
+            <a:ext cx="742511" cy="369332"/>
+          </a:xfrm>
+          <a:prstGeom prst="rect">
+            <a:avLst/>
+          </a:prstGeom>
+          <a:solidFill>
+            <a:schemeClr val="accent1">
+              <a:lumMod val="20000"/>
+              <a:lumOff val="80000"/>
+            </a:schemeClr>
+          </a:solidFill>
+        </p:spPr>
+        <p:txBody>
+          <a:bodyPr wrap="none" rtlCol="0">
+            <a:spAutoFit/>
+          </a:bodyPr>
+          <a:lstStyle/>
+          <a:p>
+            <a:r>
+              <a:rPr lang="fr-CH" dirty="0"/>
+              <a:t>ID = 0</a:t>
+            </a:r>
+          </a:p>
+        </p:txBody>
+      </p:sp>
+      <p:cxnSp>
+        <p:nvCxnSpPr>
+          <p:cNvPr id="14" name="Straight Arrow Connector 13">
+            <a:extLst>
+              <a:ext uri="{FF2B5EF4-FFF2-40B4-BE49-F238E27FC236}">
+                <a16:creationId xmlns:a16="http://schemas.microsoft.com/office/drawing/2014/main" id="{0BCDBC56-0A5F-548A-7A5B-A2304B0D9506}"/>
+              </a:ext>
+            </a:extLst>
+          </p:cNvPr>
+          <p:cNvCxnSpPr>
+            <a:cxnSpLocks/>
+            <a:stCxn id="12" idx="1"/>
+          </p:cNvCxnSpPr>
+          <p:nvPr/>
+        </p:nvCxnSpPr>
+        <p:spPr>
+          <a:xfrm flipH="1">
+            <a:off x="4362450" y="1758525"/>
+            <a:ext cx="2615183" cy="0"/>
+          </a:xfrm>
+          <a:prstGeom prst="straightConnector1">
+            <a:avLst/>
+          </a:prstGeom>
+          <a:ln w="57150">
+            <a:tailEnd type="triangle"/>
+          </a:ln>
+        </p:spPr>
+        <p:style>
+          <a:lnRef idx="2">
+            <a:schemeClr val="accent1"/>
+          </a:lnRef>
+          <a:fillRef idx="0">
+            <a:schemeClr val="accent1"/>
+          </a:fillRef>
+          <a:effectRef idx="1">
+            <a:schemeClr val="accent1"/>
+          </a:effectRef>
+          <a:fontRef idx="minor">
+            <a:schemeClr val="tx1"/>
+          </a:fontRef>
+        </p:style>
+      </p:cxnSp>
+      <p:sp>
+        <p:nvSpPr>
+          <p:cNvPr id="15" name="TextBox 14">
+            <a:extLst>
+              <a:ext uri="{FF2B5EF4-FFF2-40B4-BE49-F238E27FC236}">
+                <a16:creationId xmlns:a16="http://schemas.microsoft.com/office/drawing/2014/main" id="{483F7ABF-B9F3-7968-6BD5-AFA8573116DD}"/>
+              </a:ext>
+            </a:extLst>
+          </p:cNvPr>
+          <p:cNvSpPr txBox="1"/>
+          <p:nvPr/>
+        </p:nvSpPr>
+        <p:spPr>
+          <a:xfrm>
+            <a:off x="6985713" y="1943191"/>
+            <a:ext cx="742511" cy="369332"/>
+          </a:xfrm>
+          <a:prstGeom prst="rect">
+            <a:avLst/>
+          </a:prstGeom>
+          <a:solidFill>
+            <a:schemeClr val="accent1">
+              <a:lumMod val="20000"/>
+              <a:lumOff val="80000"/>
+            </a:schemeClr>
+          </a:solidFill>
+        </p:spPr>
+        <p:txBody>
+          <a:bodyPr wrap="none" rtlCol="0">
+            <a:spAutoFit/>
+          </a:bodyPr>
+          <a:lstStyle/>
+          <a:p>
+            <a:r>
+              <a:rPr lang="fr-CH" dirty="0"/>
+              <a:t>ID = 1</a:t>
+            </a:r>
+          </a:p>
+        </p:txBody>
+      </p:sp>
+      <p:cxnSp>
+        <p:nvCxnSpPr>
+          <p:cNvPr id="17" name="Straight Arrow Connector 16">
+            <a:extLst>
+              <a:ext uri="{FF2B5EF4-FFF2-40B4-BE49-F238E27FC236}">
+                <a16:creationId xmlns:a16="http://schemas.microsoft.com/office/drawing/2014/main" id="{5F498970-6C1F-B039-9212-A003E72514E3}"/>
+              </a:ext>
+            </a:extLst>
+          </p:cNvPr>
+          <p:cNvCxnSpPr>
+            <a:cxnSpLocks/>
+            <a:stCxn id="15" idx="1"/>
+          </p:cNvCxnSpPr>
+          <p:nvPr/>
+        </p:nvCxnSpPr>
+        <p:spPr>
+          <a:xfrm flipH="1">
+            <a:off x="4421981" y="2127857"/>
+            <a:ext cx="2563732" cy="58131"/>
+          </a:xfrm>
+          <a:prstGeom prst="straightConnector1">
+            <a:avLst/>
+          </a:prstGeom>
+          <a:ln w="57150">
+            <a:tailEnd type="triangle"/>
+          </a:ln>
+        </p:spPr>
+        <p:style>
+          <a:lnRef idx="2">
+            <a:schemeClr val="accent1"/>
+          </a:lnRef>
+          <a:fillRef idx="0">
+            <a:schemeClr val="accent1"/>
+          </a:fillRef>
+          <a:effectRef idx="1">
+            <a:schemeClr val="accent1"/>
+          </a:effectRef>
+          <a:fontRef idx="minor">
+            <a:schemeClr val="tx1"/>
+          </a:fontRef>
+        </p:style>
+      </p:cxnSp>
+      <p:sp>
+        <p:nvSpPr>
+          <p:cNvPr id="7" name="TextBox 6">
+            <a:extLst>
+              <a:ext uri="{FF2B5EF4-FFF2-40B4-BE49-F238E27FC236}">
+                <a16:creationId xmlns:a16="http://schemas.microsoft.com/office/drawing/2014/main" id="{D062759F-D1FF-9901-6B9B-7A0880E7B9AA}"/>
+              </a:ext>
+            </a:extLst>
+          </p:cNvPr>
+          <p:cNvSpPr txBox="1"/>
+          <p:nvPr/>
+        </p:nvSpPr>
+        <p:spPr>
+          <a:xfrm>
+            <a:off x="6993793" y="2312523"/>
+            <a:ext cx="742511" cy="369332"/>
+          </a:xfrm>
+          <a:prstGeom prst="rect">
+            <a:avLst/>
+          </a:prstGeom>
+          <a:solidFill>
+            <a:schemeClr val="accent1">
+              <a:lumMod val="20000"/>
+              <a:lumOff val="80000"/>
+            </a:schemeClr>
+          </a:solidFill>
+        </p:spPr>
+        <p:txBody>
+          <a:bodyPr wrap="none" rtlCol="0">
+            <a:spAutoFit/>
+          </a:bodyPr>
+          <a:lstStyle/>
+          <a:p>
+            <a:r>
+              <a:rPr lang="fr-CH" dirty="0"/>
+              <a:t>ID = 2</a:t>
+            </a:r>
+          </a:p>
+        </p:txBody>
+      </p:sp>
+      <p:cxnSp>
+        <p:nvCxnSpPr>
+          <p:cNvPr id="13" name="Straight Arrow Connector 12">
+            <a:extLst>
+              <a:ext uri="{FF2B5EF4-FFF2-40B4-BE49-F238E27FC236}">
+                <a16:creationId xmlns:a16="http://schemas.microsoft.com/office/drawing/2014/main" id="{223C89D1-0396-C5BF-C860-08911CD39563}"/>
+              </a:ext>
+            </a:extLst>
+          </p:cNvPr>
+          <p:cNvCxnSpPr>
+            <a:cxnSpLocks/>
+            <a:stCxn id="7" idx="1"/>
+          </p:cNvCxnSpPr>
+          <p:nvPr/>
+        </p:nvCxnSpPr>
+        <p:spPr>
+          <a:xfrm flipH="1">
+            <a:off x="4344976" y="2497189"/>
+            <a:ext cx="2648817" cy="168819"/>
+          </a:xfrm>
+          <a:prstGeom prst="straightConnector1">
+            <a:avLst/>
+          </a:prstGeom>
+          <a:ln w="57150">
+            <a:tailEnd type="triangle"/>
+          </a:ln>
+        </p:spPr>
+        <p:style>
+          <a:lnRef idx="2">
+            <a:schemeClr val="accent1"/>
+          </a:lnRef>
+          <a:fillRef idx="0">
+            <a:schemeClr val="accent1"/>
+          </a:fillRef>
+          <a:effectRef idx="1">
+            <a:schemeClr val="accent1"/>
+          </a:effectRef>
+          <a:fontRef idx="minor">
+            <a:schemeClr val="tx1"/>
+          </a:fontRef>
+        </p:style>
+      </p:cxnSp>
+    </p:spTree>
+    <p:extLst>
+      <p:ext uri="{BB962C8B-B14F-4D97-AF65-F5344CB8AC3E}">
+        <p14:creationId xmlns:p14="http://schemas.microsoft.com/office/powerpoint/2010/main" val="2223830467"/>
+      </p:ext>
+    </p:extLst>
+  </p:cSld>
+  <p:clrMapOvr>
+    <a:masterClrMapping/>
+  </p:clrMapOvr>
+</p:sld>
+</file>
+
+<file path=ppt/slides/slide4.xml><?xml version="1.0" encoding="utf-8"?>
+<p:sld xmlns:a="http://schemas.openxmlformats.org/drawingml/2006/main" xmlns:r="http://schemas.openxmlformats.org/officeDocument/2006/relationships" xmlns:p="http://schemas.openxmlformats.org/presentationml/2006/main">
+  <p:cSld>
+    <p:spTree>
+      <p:nvGrpSpPr>
+        <p:cNvPr id="1" name=""/>
+        <p:cNvGrpSpPr/>
+        <p:nvPr/>
+      </p:nvGrpSpPr>
+      <p:grpSpPr>
+        <a:xfrm>
+          <a:off x="0" y="0"/>
+          <a:ext cx="0" cy="0"/>
+          <a:chOff x="0" y="0"/>
+          <a:chExt cx="0" cy="0"/>
+        </a:xfrm>
+      </p:grpSpPr>
+      <p:pic>
+        <p:nvPicPr>
+          <p:cNvPr id="3" name="Picture 2">
+            <a:extLst>
+              <a:ext uri="{FF2B5EF4-FFF2-40B4-BE49-F238E27FC236}">
+                <a16:creationId xmlns:a16="http://schemas.microsoft.com/office/drawing/2014/main" id="{3C445B66-335A-9A48-9632-4F5D2352236C}"/>
+              </a:ext>
+            </a:extLst>
+          </p:cNvPr>
+          <p:cNvPicPr>
+            <a:picLocks noChangeAspect="1"/>
+          </p:cNvPicPr>
+          <p:nvPr/>
+        </p:nvPicPr>
+        <p:blipFill>
+          <a:blip r:embed="rId2"/>
+          <a:stretch>
+            <a:fillRect/>
+          </a:stretch>
+        </p:blipFill>
+        <p:spPr>
+          <a:xfrm>
+            <a:off x="3733470" y="1166497"/>
+            <a:ext cx="4725059" cy="4525006"/>
+          </a:xfrm>
+          <a:prstGeom prst="rect">
+            <a:avLst/>
+          </a:prstGeom>
+        </p:spPr>
+      </p:pic>
+      <p:sp>
+        <p:nvSpPr>
+          <p:cNvPr id="8" name="TextBox 7">
+            <a:extLst>
+              <a:ext uri="{FF2B5EF4-FFF2-40B4-BE49-F238E27FC236}">
+                <a16:creationId xmlns:a16="http://schemas.microsoft.com/office/drawing/2014/main" id="{E1C186AF-7EEB-2581-7D9B-6B8B96AD8C3F}"/>
+              </a:ext>
+            </a:extLst>
+          </p:cNvPr>
+          <p:cNvSpPr txBox="1"/>
+          <p:nvPr/>
+        </p:nvSpPr>
+        <p:spPr>
+          <a:xfrm>
+            <a:off x="4348244" y="4026387"/>
+            <a:ext cx="1310615" cy="369332"/>
+          </a:xfrm>
+          <a:prstGeom prst="rect">
+            <a:avLst/>
+          </a:prstGeom>
+          <a:solidFill>
+            <a:schemeClr val="accent1">
+              <a:lumMod val="20000"/>
+              <a:lumOff val="80000"/>
+            </a:schemeClr>
+          </a:solidFill>
+        </p:spPr>
+        <p:txBody>
+          <a:bodyPr wrap="none" rtlCol="0">
+            <a:spAutoFit/>
+          </a:bodyPr>
+          <a:lstStyle/>
+          <a:p>
+            <a:r>
+              <a:rPr lang="fr-CH" dirty="0"/>
+              <a:t>X = 12,Y=12</a:t>
+            </a:r>
+          </a:p>
+        </p:txBody>
+      </p:sp>
+      <p:cxnSp>
+        <p:nvCxnSpPr>
+          <p:cNvPr id="10" name="Straight Arrow Connector 9">
+            <a:extLst>
+              <a:ext uri="{FF2B5EF4-FFF2-40B4-BE49-F238E27FC236}">
+                <a16:creationId xmlns:a16="http://schemas.microsoft.com/office/drawing/2014/main" id="{2A2455B2-E6E8-38B8-33E6-FFD6CDE767CB}"/>
+              </a:ext>
+            </a:extLst>
+          </p:cNvPr>
+          <p:cNvCxnSpPr>
+            <a:cxnSpLocks/>
+            <a:stCxn id="8" idx="3"/>
+          </p:cNvCxnSpPr>
+          <p:nvPr/>
+        </p:nvCxnSpPr>
+        <p:spPr>
+          <a:xfrm>
+            <a:off x="5658859" y="4211053"/>
+            <a:ext cx="928430" cy="66173"/>
+          </a:xfrm>
+          <a:prstGeom prst="straightConnector1">
+            <a:avLst/>
+          </a:prstGeom>
+          <a:ln>
+            <a:tailEnd type="triangle"/>
+          </a:ln>
+        </p:spPr>
+        <p:style>
+          <a:lnRef idx="2">
+            <a:schemeClr val="accent1"/>
+          </a:lnRef>
+          <a:fillRef idx="0">
+            <a:schemeClr val="accent1"/>
+          </a:fillRef>
+          <a:effectRef idx="1">
+            <a:schemeClr val="accent1"/>
+          </a:effectRef>
+          <a:fontRef idx="minor">
+            <a:schemeClr val="tx1"/>
+          </a:fontRef>
+        </p:style>
+      </p:cxnSp>
+      <p:sp>
+        <p:nvSpPr>
+          <p:cNvPr id="12" name="TextBox 11">
+            <a:extLst>
+              <a:ext uri="{FF2B5EF4-FFF2-40B4-BE49-F238E27FC236}">
+                <a16:creationId xmlns:a16="http://schemas.microsoft.com/office/drawing/2014/main" id="{EDDB3A8B-DF75-7A24-DA14-8D686C95A2D0}"/>
+              </a:ext>
+            </a:extLst>
+          </p:cNvPr>
+          <p:cNvSpPr txBox="1"/>
+          <p:nvPr/>
+        </p:nvSpPr>
+        <p:spPr>
+          <a:xfrm>
+            <a:off x="8962843" y="4347138"/>
+            <a:ext cx="742511" cy="369332"/>
+          </a:xfrm>
+          <a:prstGeom prst="rect">
+            <a:avLst/>
+          </a:prstGeom>
+          <a:solidFill>
+            <a:schemeClr val="accent1">
+              <a:lumMod val="20000"/>
+              <a:lumOff val="80000"/>
+            </a:schemeClr>
+          </a:solidFill>
+        </p:spPr>
+        <p:txBody>
+          <a:bodyPr wrap="none" rtlCol="0">
+            <a:spAutoFit/>
+          </a:bodyPr>
+          <a:lstStyle/>
+          <a:p>
+            <a:r>
+              <a:rPr lang="fr-CH" dirty="0"/>
+              <a:t>ID = 0</a:t>
+            </a:r>
+          </a:p>
+        </p:txBody>
+      </p:sp>
+      <p:cxnSp>
+        <p:nvCxnSpPr>
+          <p:cNvPr id="14" name="Straight Arrow Connector 13">
+            <a:extLst>
+              <a:ext uri="{FF2B5EF4-FFF2-40B4-BE49-F238E27FC236}">
+                <a16:creationId xmlns:a16="http://schemas.microsoft.com/office/drawing/2014/main" id="{0BCDBC56-0A5F-548A-7A5B-A2304B0D9506}"/>
+              </a:ext>
+            </a:extLst>
+          </p:cNvPr>
+          <p:cNvCxnSpPr>
+            <a:cxnSpLocks/>
+            <a:stCxn id="12" idx="1"/>
+          </p:cNvCxnSpPr>
+          <p:nvPr/>
+        </p:nvCxnSpPr>
+        <p:spPr>
+          <a:xfrm flipH="1" flipV="1">
+            <a:off x="8151395" y="4481763"/>
+            <a:ext cx="811448" cy="50041"/>
+          </a:xfrm>
+          <a:prstGeom prst="straightConnector1">
+            <a:avLst/>
+          </a:prstGeom>
+          <a:ln w="57150">
+            <a:tailEnd type="triangle"/>
+          </a:ln>
+        </p:spPr>
+        <p:style>
+          <a:lnRef idx="2">
+            <a:schemeClr val="accent1"/>
+          </a:lnRef>
+          <a:fillRef idx="0">
+            <a:schemeClr val="accent1"/>
+          </a:fillRef>
+          <a:effectRef idx="1">
+            <a:schemeClr val="accent1"/>
+          </a:effectRef>
+          <a:fontRef idx="minor">
+            <a:schemeClr val="tx1"/>
+          </a:fontRef>
+        </p:style>
+      </p:cxnSp>
+      <p:sp>
+        <p:nvSpPr>
+          <p:cNvPr id="15" name="TextBox 14">
+            <a:extLst>
+              <a:ext uri="{FF2B5EF4-FFF2-40B4-BE49-F238E27FC236}">
+                <a16:creationId xmlns:a16="http://schemas.microsoft.com/office/drawing/2014/main" id="{483F7ABF-B9F3-7968-6BD5-AFA8573116DD}"/>
+              </a:ext>
+            </a:extLst>
+          </p:cNvPr>
+          <p:cNvSpPr txBox="1"/>
+          <p:nvPr/>
+        </p:nvSpPr>
+        <p:spPr>
+          <a:xfrm>
+            <a:off x="8970923" y="4716470"/>
+            <a:ext cx="742511" cy="369332"/>
+          </a:xfrm>
+          <a:prstGeom prst="rect">
+            <a:avLst/>
+          </a:prstGeom>
+          <a:solidFill>
+            <a:schemeClr val="accent1">
+              <a:lumMod val="20000"/>
+              <a:lumOff val="80000"/>
+            </a:schemeClr>
+          </a:solidFill>
+        </p:spPr>
+        <p:txBody>
+          <a:bodyPr wrap="none" rtlCol="0">
+            <a:spAutoFit/>
+          </a:bodyPr>
+          <a:lstStyle/>
+          <a:p>
+            <a:r>
+              <a:rPr lang="fr-CH" dirty="0"/>
+              <a:t>ID = 1</a:t>
+            </a:r>
+          </a:p>
+        </p:txBody>
+      </p:sp>
+      <p:cxnSp>
+        <p:nvCxnSpPr>
+          <p:cNvPr id="17" name="Straight Arrow Connector 16">
+            <a:extLst>
+              <a:ext uri="{FF2B5EF4-FFF2-40B4-BE49-F238E27FC236}">
+                <a16:creationId xmlns:a16="http://schemas.microsoft.com/office/drawing/2014/main" id="{5F498970-6C1F-B039-9212-A003E72514E3}"/>
+              </a:ext>
+            </a:extLst>
+          </p:cNvPr>
+          <p:cNvCxnSpPr>
+            <a:cxnSpLocks/>
+            <a:stCxn id="15" idx="1"/>
+          </p:cNvCxnSpPr>
+          <p:nvPr/>
+        </p:nvCxnSpPr>
+        <p:spPr>
+          <a:xfrm flipH="1">
+            <a:off x="8007016" y="4901136"/>
+            <a:ext cx="963907" cy="63267"/>
+          </a:xfrm>
+          <a:prstGeom prst="straightConnector1">
+            <a:avLst/>
+          </a:prstGeom>
+          <a:ln w="57150">
+            <a:tailEnd type="triangle"/>
+          </a:ln>
+        </p:spPr>
+        <p:style>
+          <a:lnRef idx="2">
+            <a:schemeClr val="accent1"/>
+          </a:lnRef>
+          <a:fillRef idx="0">
+            <a:schemeClr val="accent1"/>
+          </a:fillRef>
+          <a:effectRef idx="1">
+            <a:schemeClr val="accent1"/>
+          </a:effectRef>
+          <a:fontRef idx="minor">
+            <a:schemeClr val="tx1"/>
+          </a:fontRef>
+        </p:style>
+      </p:cxnSp>
+      <p:sp>
+        <p:nvSpPr>
+          <p:cNvPr id="7" name="TextBox 6">
+            <a:extLst>
+              <a:ext uri="{FF2B5EF4-FFF2-40B4-BE49-F238E27FC236}">
+                <a16:creationId xmlns:a16="http://schemas.microsoft.com/office/drawing/2014/main" id="{D062759F-D1FF-9901-6B9B-7A0880E7B9AA}"/>
+              </a:ext>
+            </a:extLst>
+          </p:cNvPr>
+          <p:cNvSpPr txBox="1"/>
+          <p:nvPr/>
+        </p:nvSpPr>
+        <p:spPr>
+          <a:xfrm>
+            <a:off x="8979003" y="5085802"/>
+            <a:ext cx="742511" cy="369332"/>
+          </a:xfrm>
+          <a:prstGeom prst="rect">
+            <a:avLst/>
+          </a:prstGeom>
+          <a:solidFill>
+            <a:schemeClr val="accent1">
+              <a:lumMod val="20000"/>
+              <a:lumOff val="80000"/>
+            </a:schemeClr>
+          </a:solidFill>
+        </p:spPr>
+        <p:txBody>
+          <a:bodyPr wrap="none" rtlCol="0">
+            <a:spAutoFit/>
+          </a:bodyPr>
+          <a:lstStyle/>
+          <a:p>
+            <a:r>
+              <a:rPr lang="fr-CH" dirty="0"/>
+              <a:t>ID = 2</a:t>
+            </a:r>
+          </a:p>
+        </p:txBody>
+      </p:sp>
+      <p:cxnSp>
+        <p:nvCxnSpPr>
+          <p:cNvPr id="13" name="Straight Arrow Connector 12">
+            <a:extLst>
+              <a:ext uri="{FF2B5EF4-FFF2-40B4-BE49-F238E27FC236}">
+                <a16:creationId xmlns:a16="http://schemas.microsoft.com/office/drawing/2014/main" id="{223C89D1-0396-C5BF-C860-08911CD39563}"/>
+              </a:ext>
+            </a:extLst>
+          </p:cNvPr>
+          <p:cNvCxnSpPr>
+            <a:cxnSpLocks/>
+            <a:stCxn id="7" idx="1"/>
+          </p:cNvCxnSpPr>
+          <p:nvPr/>
+        </p:nvCxnSpPr>
+        <p:spPr>
+          <a:xfrm flipH="1">
+            <a:off x="8151395" y="5270468"/>
+            <a:ext cx="827608" cy="94474"/>
+          </a:xfrm>
+          <a:prstGeom prst="straightConnector1">
+            <a:avLst/>
+          </a:prstGeom>
+          <a:ln w="57150">
+            <a:tailEnd type="triangle"/>
+          </a:ln>
+        </p:spPr>
+        <p:style>
+          <a:lnRef idx="2">
+            <a:schemeClr val="accent1"/>
+          </a:lnRef>
+          <a:fillRef idx="0">
+            <a:schemeClr val="accent1"/>
+          </a:fillRef>
+          <a:effectRef idx="1">
+            <a:schemeClr val="accent1"/>
+          </a:effectRef>
+          <a:fontRef idx="minor">
+            <a:schemeClr val="tx1"/>
+          </a:fontRef>
+        </p:style>
+      </p:cxnSp>
+    </p:spTree>
+    <p:extLst>
+      <p:ext uri="{BB962C8B-B14F-4D97-AF65-F5344CB8AC3E}">
+        <p14:creationId xmlns:p14="http://schemas.microsoft.com/office/powerpoint/2010/main" val="3891940763"/>
+      </p:ext>
+    </p:extLst>
+  </p:cSld>
+  <p:clrMapOvr>
+    <a:masterClrMapping/>
+  </p:clrMapOvr>
+</p:sld>
+</file>
+
+<file path=ppt/slides/slide5.xml><?xml version="1.0" encoding="utf-8"?>
+<p:sld xmlns:a="http://schemas.openxmlformats.org/drawingml/2006/main" xmlns:r="http://schemas.openxmlformats.org/officeDocument/2006/relationships" xmlns:p="http://schemas.openxmlformats.org/presentationml/2006/main">
+  <p:cSld>
+    <p:spTree>
+      <p:nvGrpSpPr>
+        <p:cNvPr id="1" name=""/>
+        <p:cNvGrpSpPr/>
+        <p:nvPr/>
+      </p:nvGrpSpPr>
+      <p:grpSpPr>
+        <a:xfrm>
+          <a:off x="0" y="0"/>
+          <a:ext cx="0" cy="0"/>
+          <a:chOff x="0" y="0"/>
+          <a:chExt cx="0" cy="0"/>
+        </a:xfrm>
+      </p:grpSpPr>
+      <p:pic>
+        <p:nvPicPr>
+          <p:cNvPr id="5" name="Picture 4">
+            <a:extLst>
+              <a:ext uri="{FF2B5EF4-FFF2-40B4-BE49-F238E27FC236}">
+                <a16:creationId xmlns:a16="http://schemas.microsoft.com/office/drawing/2014/main" id="{2B4E9C1D-129B-A2DA-9CD3-CBD536ED346F}"/>
+              </a:ext>
+            </a:extLst>
+          </p:cNvPr>
+          <p:cNvPicPr>
+            <a:picLocks noChangeAspect="1"/>
+          </p:cNvPicPr>
+          <p:nvPr/>
+        </p:nvPicPr>
+        <p:blipFill>
+          <a:blip r:embed="rId2"/>
+          <a:srcRect l="9958" t="5328" r="7937" b="9655"/>
+          <a:stretch/>
+        </p:blipFill>
+        <p:spPr>
+          <a:xfrm>
+            <a:off x="553583" y="2935707"/>
+            <a:ext cx="3039215" cy="2965784"/>
+          </a:xfrm>
+          <a:prstGeom prst="rect">
+            <a:avLst/>
+          </a:prstGeom>
+        </p:spPr>
+      </p:pic>
+      <p:pic>
+        <p:nvPicPr>
+          <p:cNvPr id="7" name="Picture 6">
+            <a:extLst>
+              <a:ext uri="{FF2B5EF4-FFF2-40B4-BE49-F238E27FC236}">
+                <a16:creationId xmlns:a16="http://schemas.microsoft.com/office/drawing/2014/main" id="{22F28616-AF00-F103-A2D0-2D5E53CADD02}"/>
+              </a:ext>
+            </a:extLst>
+          </p:cNvPr>
+          <p:cNvPicPr>
+            <a:picLocks noChangeAspect="1"/>
+          </p:cNvPicPr>
+          <p:nvPr/>
+        </p:nvPicPr>
+        <p:blipFill>
+          <a:blip r:embed="rId3"/>
+          <a:srcRect l="5641" t="4531"/>
+          <a:stretch/>
+        </p:blipFill>
+        <p:spPr>
+          <a:xfrm>
+            <a:off x="4415589" y="2935707"/>
+            <a:ext cx="3039215" cy="2964904"/>
+          </a:xfrm>
+          <a:prstGeom prst="rect">
+            <a:avLst/>
+          </a:prstGeom>
+        </p:spPr>
+      </p:pic>
+      <p:pic>
+        <p:nvPicPr>
+          <p:cNvPr id="9" name="Picture 8">
+            <a:extLst>
+              <a:ext uri="{FF2B5EF4-FFF2-40B4-BE49-F238E27FC236}">
+                <a16:creationId xmlns:a16="http://schemas.microsoft.com/office/drawing/2014/main" id="{7E643971-932C-A8E1-38BD-FF2535361052}"/>
+              </a:ext>
+            </a:extLst>
+          </p:cNvPr>
+          <p:cNvPicPr>
+            <a:picLocks noChangeAspect="1"/>
+          </p:cNvPicPr>
+          <p:nvPr/>
+        </p:nvPicPr>
+        <p:blipFill>
+          <a:blip r:embed="rId4"/>
+          <a:srcRect l="1390" t="4465" r="3252" b="1464"/>
+          <a:stretch/>
+        </p:blipFill>
+        <p:spPr>
+          <a:xfrm>
+            <a:off x="8704848" y="2935707"/>
+            <a:ext cx="3092384" cy="2964904"/>
+          </a:xfrm>
+          <a:prstGeom prst="rect">
+            <a:avLst/>
+          </a:prstGeom>
+        </p:spPr>
+      </p:pic>
+      <p:sp>
+        <p:nvSpPr>
+          <p:cNvPr id="10" name="Arrow: Right 9">
+            <a:extLst>
+              <a:ext uri="{FF2B5EF4-FFF2-40B4-BE49-F238E27FC236}">
+                <a16:creationId xmlns:a16="http://schemas.microsoft.com/office/drawing/2014/main" id="{65EC33FF-A971-0499-31CC-2C79880DB2B4}"/>
+              </a:ext>
+            </a:extLst>
+          </p:cNvPr>
+          <p:cNvSpPr/>
+          <p:nvPr/>
+        </p:nvSpPr>
+        <p:spPr>
+          <a:xfrm>
+            <a:off x="3592798" y="4180974"/>
+            <a:ext cx="618255" cy="517358"/>
+          </a:xfrm>
+          <a:prstGeom prst="rightArrow">
+            <a:avLst/>
+          </a:prstGeom>
+        </p:spPr>
+        <p:style>
+          <a:lnRef idx="2">
+            <a:schemeClr val="accent1">
+              <a:shade val="15000"/>
+            </a:schemeClr>
+          </a:lnRef>
+          <a:fillRef idx="1">
+            <a:schemeClr val="accent1"/>
+          </a:fillRef>
+          <a:effectRef idx="0">
+            <a:schemeClr val="accent1"/>
+          </a:effectRef>
+          <a:fontRef idx="minor">
+            <a:schemeClr val="lt1"/>
+          </a:fontRef>
+        </p:style>
+        <p:txBody>
+          <a:bodyPr rtlCol="0" anchor="ctr"/>
+          <a:lstStyle/>
+          <a:p>
+            <a:pPr algn="ctr"/>
+            <a:endParaRPr lang="fr-CH"/>
+          </a:p>
+        </p:txBody>
+      </p:sp>
+      <p:sp>
+        <p:nvSpPr>
+          <p:cNvPr id="11" name="Arrow: Right 10">
+            <a:extLst>
+              <a:ext uri="{FF2B5EF4-FFF2-40B4-BE49-F238E27FC236}">
+                <a16:creationId xmlns:a16="http://schemas.microsoft.com/office/drawing/2014/main" id="{80BB77BD-8C3C-D9AA-4765-EC638C0238CB}"/>
+              </a:ext>
+            </a:extLst>
+          </p:cNvPr>
+          <p:cNvSpPr/>
+          <p:nvPr/>
+        </p:nvSpPr>
+        <p:spPr>
+          <a:xfrm>
+            <a:off x="7659340" y="4180974"/>
+            <a:ext cx="618255" cy="517358"/>
+          </a:xfrm>
+          <a:prstGeom prst="rightArrow">
+            <a:avLst/>
+          </a:prstGeom>
+        </p:spPr>
+        <p:style>
+          <a:lnRef idx="2">
+            <a:schemeClr val="accent1">
+              <a:shade val="15000"/>
+            </a:schemeClr>
+          </a:lnRef>
+          <a:fillRef idx="1">
+            <a:schemeClr val="accent1"/>
+          </a:fillRef>
+          <a:effectRef idx="0">
+            <a:schemeClr val="accent1"/>
+          </a:effectRef>
+          <a:fontRef idx="minor">
+            <a:schemeClr val="lt1"/>
+          </a:fontRef>
+        </p:style>
+        <p:txBody>
+          <a:bodyPr rtlCol="0" anchor="ctr"/>
+          <a:lstStyle/>
+          <a:p>
+            <a:pPr algn="ctr"/>
+            <a:endParaRPr lang="fr-CH"/>
+          </a:p>
+        </p:txBody>
+      </p:sp>
+      <p:sp>
+        <p:nvSpPr>
+          <p:cNvPr id="12" name="TextBox 11">
+            <a:extLst>
+              <a:ext uri="{FF2B5EF4-FFF2-40B4-BE49-F238E27FC236}">
+                <a16:creationId xmlns:a16="http://schemas.microsoft.com/office/drawing/2014/main" id="{81829220-D822-B0E5-E3C1-680A7B40005D}"/>
+              </a:ext>
+            </a:extLst>
+          </p:cNvPr>
+          <p:cNvSpPr txBox="1"/>
+          <p:nvPr/>
+        </p:nvSpPr>
+        <p:spPr>
+          <a:xfrm>
+            <a:off x="866274" y="1094874"/>
+            <a:ext cx="2568011" cy="369332"/>
+          </a:xfrm>
+          <a:prstGeom prst="rect">
+            <a:avLst/>
+          </a:prstGeom>
+          <a:noFill/>
+        </p:spPr>
+        <p:txBody>
+          <a:bodyPr wrap="none" rtlCol="0">
+            <a:spAutoFit/>
+          </a:bodyPr>
+          <a:lstStyle/>
+          <a:p>
+            <a:r>
+              <a:rPr lang="fr-CH" dirty="0"/>
+              <a:t>Just </a:t>
+            </a:r>
+            <a:r>
+              <a:rPr lang="fr-CH" dirty="0" err="1"/>
+              <a:t>after</a:t>
+            </a:r>
+            <a:r>
+              <a:rPr lang="fr-CH" dirty="0"/>
+              <a:t> </a:t>
+            </a:r>
+            <a:r>
+              <a:rPr lang="fr-CH" dirty="0" err="1"/>
+              <a:t>switching</a:t>
+            </a:r>
+            <a:r>
+              <a:rPr lang="fr-CH" dirty="0"/>
+              <a:t> </a:t>
+            </a:r>
+            <a:r>
+              <a:rPr lang="fr-CH" dirty="0" err="1"/>
+              <a:t>pkm</a:t>
+            </a:r>
+            <a:endParaRPr lang="fr-CH" dirty="0"/>
+          </a:p>
+        </p:txBody>
+      </p:sp>
+    </p:spTree>
+    <p:extLst>
+      <p:ext uri="{BB962C8B-B14F-4D97-AF65-F5344CB8AC3E}">
+        <p14:creationId xmlns:p14="http://schemas.microsoft.com/office/powerpoint/2010/main" val="638409082"/>
+      </p:ext>
+    </p:extLst>
+  </p:cSld>
+  <p:clrMapOvr>
+    <a:masterClrMapping/>
+  </p:clrMapOvr>
+</p:sld>
+</file>
+
 <file path=ppt/theme/theme1.xml><?xml version="1.0" encoding="utf-8"?>
 <a:theme xmlns:a="http://schemas.openxmlformats.org/drawingml/2006/main" name="Office Theme">
   <a:themeElements>

</xml_diff>